<commit_message>
Fixed a bug with data folders.
</commit_message>
<xml_diff>
--- a/tuts/antupy.pptx
+++ b/tuts/antupy.pptx
@@ -16,6 +16,7 @@
     <p:sldId id="275" r:id="rId10"/>
     <p:sldId id="270" r:id="rId11"/>
     <p:sldId id="260" r:id="rId12"/>
+    <p:sldId id="276" r:id="rId13"/>
   </p:sldIdLst>
   <p:sldSz cx="12192000" cy="6858000"/>
   <p:notesSz cx="6858000" cy="9144000"/>
@@ -3734,6 +3735,108 @@
 </p:sld>
 </file>
 
+<file path=ppt/slides/slide12.xml><?xml version="1.0" encoding="utf-8"?>
+<p:sld xmlns:a="http://schemas.openxmlformats.org/drawingml/2006/main" xmlns:r="http://schemas.openxmlformats.org/officeDocument/2006/relationships" xmlns:p="http://schemas.openxmlformats.org/presentationml/2006/main">
+  <p:cSld>
+    <p:spTree>
+      <p:nvGrpSpPr>
+        <p:cNvPr id="1" name="">
+          <a:extLst>
+            <a:ext uri="{FF2B5EF4-FFF2-40B4-BE49-F238E27FC236}">
+              <a16:creationId xmlns:a16="http://schemas.microsoft.com/office/drawing/2014/main" id="{2FD66F45-12FE-F11D-77AD-3EB78083956E}"/>
+            </a:ext>
+          </a:extLst>
+        </p:cNvPr>
+        <p:cNvGrpSpPr/>
+        <p:nvPr/>
+      </p:nvGrpSpPr>
+      <p:grpSpPr>
+        <a:xfrm>
+          <a:off x="0" y="0"/>
+          <a:ext cx="0" cy="0"/>
+          <a:chOff x="0" y="0"/>
+          <a:chExt cx="0" cy="0"/>
+        </a:xfrm>
+      </p:grpSpPr>
+      <p:sp>
+        <p:nvSpPr>
+          <p:cNvPr id="2" name="Title 1">
+            <a:extLst>
+              <a:ext uri="{FF2B5EF4-FFF2-40B4-BE49-F238E27FC236}">
+                <a16:creationId xmlns:a16="http://schemas.microsoft.com/office/drawing/2014/main" id="{FF124D3F-807C-2D4D-E209-2ED27B0A5580}"/>
+              </a:ext>
+            </a:extLst>
+          </p:cNvPr>
+          <p:cNvSpPr>
+            <a:spLocks noGrp="1"/>
+          </p:cNvSpPr>
+          <p:nvPr>
+            <p:ph type="title"/>
+          </p:nvPr>
+        </p:nvSpPr>
+        <p:spPr/>
+        <p:txBody>
+          <a:bodyPr/>
+          <a:lstStyle/>
+          <a:p>
+            <a:r>
+              <a:rPr lang="en-US" noProof="1"/>
+              <a:t>collaboration</a:t>
+            </a:r>
+          </a:p>
+        </p:txBody>
+      </p:sp>
+      <p:sp>
+        <p:nvSpPr>
+          <p:cNvPr id="3" name="Content Placeholder 2">
+            <a:extLst>
+              <a:ext uri="{FF2B5EF4-FFF2-40B4-BE49-F238E27FC236}">
+                <a16:creationId xmlns:a16="http://schemas.microsoft.com/office/drawing/2014/main" id="{9D8CEF2A-6DD6-D8BC-C4C3-EBE20A6B274C}"/>
+              </a:ext>
+            </a:extLst>
+          </p:cNvPr>
+          <p:cNvSpPr>
+            <a:spLocks noGrp="1"/>
+          </p:cNvSpPr>
+          <p:nvPr>
+            <p:ph idx="1"/>
+          </p:nvPr>
+        </p:nvSpPr>
+        <p:spPr>
+          <a:xfrm>
+            <a:off x="838200" y="1825625"/>
+            <a:ext cx="8936736" cy="4351338"/>
+          </a:xfrm>
+        </p:spPr>
+        <p:txBody>
+          <a:bodyPr vert="horz" lIns="91440" tIns="45720" rIns="91440" bIns="45720" rtlCol="0" anchor="t">
+            <a:normAutofit/>
+          </a:bodyPr>
+          <a:lstStyle/>
+          <a:p>
+            <a:r>
+              <a:rPr lang="en-US" noProof="1">
+                <a:hlinkClick r:id="rId2"/>
+              </a:rPr>
+              <a:t>github.com/DavidSaldivia/antupy </a:t>
+            </a:r>
+            <a:endParaRPr lang="en-US" noProof="1"/>
+          </a:p>
+        </p:txBody>
+      </p:sp>
+    </p:spTree>
+    <p:extLst>
+      <p:ext uri="{BB962C8B-B14F-4D97-AF65-F5344CB8AC3E}">
+        <p14:creationId xmlns:p14="http://schemas.microsoft.com/office/powerpoint/2010/main" val="3601317453"/>
+      </p:ext>
+    </p:extLst>
+  </p:cSld>
+  <p:clrMapOvr>
+    <a:masterClrMapping/>
+  </p:clrMapOvr>
+</p:sld>
+</file>
+
 <file path=ppt/slides/slide2.xml><?xml version="1.0" encoding="utf-8"?>
 <p:sld xmlns:a="http://schemas.openxmlformats.org/drawingml/2006/main" xmlns:r="http://schemas.openxmlformats.org/officeDocument/2006/relationships" xmlns:p="http://schemas.openxmlformats.org/presentationml/2006/main">
   <p:cSld>
@@ -3832,7 +3935,7 @@
           <a:p>
             <a:r>
               <a:rPr lang="en-US" noProof="1"/>
-              <a:t>Some definitions.</a:t>
+              <a:t>some definitions.</a:t>
             </a:r>
           </a:p>
           <a:p>
@@ -3841,7 +3944,7 @@
           <a:p>
             <a:r>
               <a:rPr lang="en-US" noProof="1"/>
-              <a:t>What is it?</a:t>
+              <a:t>what is antupy?</a:t>
             </a:r>
           </a:p>
           <a:p>
@@ -3850,7 +3953,7 @@
           <a:p>
             <a:r>
               <a:rPr lang="en-US" noProof="1"/>
-              <a:t>Why?</a:t>
+              <a:t>statement of need.</a:t>
             </a:r>
           </a:p>
           <a:p>
@@ -3859,7 +3962,7 @@
           <a:p>
             <a:r>
               <a:rPr lang="en-US" noProof="1"/>
-              <a:t>Examples.</a:t>
+              <a:t>examples.</a:t>
             </a:r>
           </a:p>
           <a:p>
@@ -3868,7 +3971,7 @@
           <a:p>
             <a:r>
               <a:rPr lang="en-US" noProof="1"/>
-              <a:t>Collaborate.</a:t>
+              <a:t>collaborate.</a:t>
             </a:r>
           </a:p>
           <a:p>
@@ -4424,7 +4527,7 @@
           <a:p>
             <a:r>
               <a:rPr lang="en-US" noProof="1"/>
-              <a:t>version: 0.6.0</a:t>
+              <a:t>latest version: 0.6.2</a:t>
             </a:r>
           </a:p>
           <a:p>
@@ -5218,7 +5321,7 @@
           <a:p>
             <a:r>
               <a:rPr lang="en-US" noProof="1"/>
-              <a:t>why? statement of need:</a:t>
+              <a:t>statement of need (why):</a:t>
             </a:r>
           </a:p>
         </p:txBody>
@@ -5421,7 +5524,7 @@
           <a:p>
             <a:r>
               <a:rPr lang="en-US" noProof="1"/>
-              <a:t>why? statement of need:</a:t>
+              <a:t>statement of need (why):</a:t>
             </a:r>
             <a:endParaRPr lang="en-US" noProof="1">
               <a:solidFill>
@@ -8130,7 +8233,7 @@
             <a:pPr lvl="1"/>
             <a:r>
               <a:rPr lang="en-US" noProof="1"/>
-              <a:t>value: float	(with alias v)</a:t>
+              <a:t>value: float	(alias v)</a:t>
             </a:r>
           </a:p>
           <a:p>

</xml_diff>

<commit_message>
Changed the structure of ddd and loc to minimise it.
</commit_message>
<xml_diff>
--- a/tuts/antupy.pptx
+++ b/tuts/antupy.pptx
@@ -3170,7 +3170,7 @@
         </p:nvSpPr>
         <p:spPr>
           <a:xfrm>
-            <a:off x="7891272" y="6565392"/>
+            <a:off x="7754112" y="6419088"/>
             <a:ext cx="4300728" cy="292608"/>
           </a:xfrm>
           <a:prstGeom prst="rect">
@@ -3179,7 +3179,7 @@
         </p:spPr>
         <p:txBody>
           <a:bodyPr vert="horz" lIns="91440" tIns="45720" rIns="91440" bIns="45720" rtlCol="0">
-            <a:normAutofit/>
+            <a:normAutofit fontScale="92500" lnSpcReduction="10000"/>
           </a:bodyPr>
           <a:lstStyle>
             <a:lvl1pPr marL="0" indent="0" algn="ctr" defTabSz="914400" rtl="0" eaLnBrk="1" latinLnBrk="0" hangingPunct="1">
@@ -3347,10 +3347,10 @@
           </a:lstStyle>
           <a:p>
             <a:r>
-              <a:rPr lang="en-US" sz="1400" noProof="1"/>
+              <a:rPr lang="en-US" sz="1600" noProof="1"/>
               <a:t>*: r. taylor, a.bruce, b. yildiz, r. barraza, j. cardemil</a:t>
             </a:r>
-            <a:endParaRPr lang="en-US" sz="1200" noProof="1"/>
+            <a:endParaRPr lang="en-US" sz="1400" noProof="1"/>
           </a:p>
         </p:txBody>
       </p:sp>
@@ -3364,6 +3364,84 @@
   <p:clrMapOvr>
     <a:masterClrMapping/>
   </p:clrMapOvr>
+  <p:timing>
+    <p:tnLst>
+      <p:par>
+        <p:cTn id="1" dur="indefinite" restart="never" nodeType="tmRoot">
+          <p:childTnLst>
+            <p:seq concurrent="1" nextAc="seek">
+              <p:cTn id="2" dur="indefinite" nodeType="mainSeq">
+                <p:childTnLst>
+                  <p:par>
+                    <p:cTn id="3" fill="hold">
+                      <p:stCondLst>
+                        <p:cond delay="indefinite"/>
+                      </p:stCondLst>
+                      <p:childTnLst>
+                        <p:par>
+                          <p:cTn id="4" fill="hold">
+                            <p:stCondLst>
+                              <p:cond delay="0"/>
+                            </p:stCondLst>
+                            <p:childTnLst>
+                              <p:par>
+                                <p:cTn id="5" presetID="1" presetClass="entr" presetSubtype="0" fill="hold" grpId="0" nodeType="clickEffect">
+                                  <p:stCondLst>
+                                    <p:cond delay="0"/>
+                                  </p:stCondLst>
+                                  <p:childTnLst>
+                                    <p:set>
+                                      <p:cBhvr>
+                                        <p:cTn id="6" dur="1" fill="hold">
+                                          <p:stCondLst>
+                                            <p:cond delay="0"/>
+                                          </p:stCondLst>
+                                        </p:cTn>
+                                        <p:tgtEl>
+                                          <p:spTgt spid="2"/>
+                                        </p:tgtEl>
+                                        <p:attrNameLst>
+                                          <p:attrName>style.visibility</p:attrName>
+                                        </p:attrNameLst>
+                                      </p:cBhvr>
+                                      <p:to>
+                                        <p:strVal val="visible"/>
+                                      </p:to>
+                                    </p:set>
+                                  </p:childTnLst>
+                                </p:cTn>
+                              </p:par>
+                            </p:childTnLst>
+                          </p:cTn>
+                        </p:par>
+                      </p:childTnLst>
+                    </p:cTn>
+                  </p:par>
+                </p:childTnLst>
+              </p:cTn>
+              <p:prevCondLst>
+                <p:cond evt="onPrev" delay="0">
+                  <p:tgtEl>
+                    <p:sldTgt/>
+                  </p:tgtEl>
+                </p:cond>
+              </p:prevCondLst>
+              <p:nextCondLst>
+                <p:cond evt="onNext" delay="0">
+                  <p:tgtEl>
+                    <p:sldTgt/>
+                  </p:tgtEl>
+                </p:cond>
+              </p:nextCondLst>
+            </p:seq>
+          </p:childTnLst>
+        </p:cTn>
+      </p:par>
+    </p:tnLst>
+    <p:bldLst>
+      <p:bldP spid="2" grpId="0"/>
+    </p:bldLst>
+  </p:timing>
 </p:sld>
 </file>
 
@@ -4427,6 +4505,84 @@
   <p:clrMapOvr>
     <a:masterClrMapping/>
   </p:clrMapOvr>
+  <p:timing>
+    <p:tnLst>
+      <p:par>
+        <p:cTn id="1" dur="indefinite" restart="never" nodeType="tmRoot">
+          <p:childTnLst>
+            <p:seq concurrent="1" nextAc="seek">
+              <p:cTn id="2" dur="indefinite" nodeType="mainSeq">
+                <p:childTnLst>
+                  <p:par>
+                    <p:cTn id="3" fill="hold">
+                      <p:stCondLst>
+                        <p:cond delay="indefinite"/>
+                      </p:stCondLst>
+                      <p:childTnLst>
+                        <p:par>
+                          <p:cTn id="4" fill="hold">
+                            <p:stCondLst>
+                              <p:cond delay="0"/>
+                            </p:stCondLst>
+                            <p:childTnLst>
+                              <p:par>
+                                <p:cTn id="5" presetID="1" presetClass="entr" presetSubtype="0" fill="hold" grpId="0" nodeType="clickEffect">
+                                  <p:stCondLst>
+                                    <p:cond delay="0"/>
+                                  </p:stCondLst>
+                                  <p:childTnLst>
+                                    <p:set>
+                                      <p:cBhvr>
+                                        <p:cTn id="6" dur="1" fill="hold">
+                                          <p:stCondLst>
+                                            <p:cond delay="0"/>
+                                          </p:stCondLst>
+                                        </p:cTn>
+                                        <p:tgtEl>
+                                          <p:spTgt spid="4"/>
+                                        </p:tgtEl>
+                                        <p:attrNameLst>
+                                          <p:attrName>style.visibility</p:attrName>
+                                        </p:attrNameLst>
+                                      </p:cBhvr>
+                                      <p:to>
+                                        <p:strVal val="visible"/>
+                                      </p:to>
+                                    </p:set>
+                                  </p:childTnLst>
+                                </p:cTn>
+                              </p:par>
+                            </p:childTnLst>
+                          </p:cTn>
+                        </p:par>
+                      </p:childTnLst>
+                    </p:cTn>
+                  </p:par>
+                </p:childTnLst>
+              </p:cTn>
+              <p:prevCondLst>
+                <p:cond evt="onPrev" delay="0">
+                  <p:tgtEl>
+                    <p:sldTgt/>
+                  </p:tgtEl>
+                </p:cond>
+              </p:prevCondLst>
+              <p:nextCondLst>
+                <p:cond evt="onNext" delay="0">
+                  <p:tgtEl>
+                    <p:sldTgt/>
+                  </p:tgtEl>
+                </p:cond>
+              </p:nextCondLst>
+            </p:seq>
+          </p:childTnLst>
+        </p:cTn>
+      </p:par>
+    </p:tnLst>
+    <p:bldLst>
+      <p:bldP spid="4" grpId="0"/>
+    </p:bldLst>
+  </p:timing>
 </p:sld>
 </file>
 
@@ -4515,7 +4671,7 @@
         </p:spPr>
         <p:txBody>
           <a:bodyPr>
-            <a:normAutofit/>
+            <a:normAutofit fontScale="92500" lnSpcReduction="20000"/>
           </a:bodyPr>
           <a:lstStyle/>
           <a:p>
@@ -4528,6 +4684,12 @@
             <a:r>
               <a:rPr lang="en-US" noProof="1"/>
               <a:t>latest version: 0.6.2</a:t>
+            </a:r>
+          </a:p>
+          <a:p>
+            <a:r>
+              <a:rPr lang="en-US" noProof="1"/>
+              <a:t>published in PyPI (pip). no yet in conda.</a:t>
             </a:r>
           </a:p>
           <a:p>
@@ -5272,6 +5434,435 @@
   <p:clrMapOvr>
     <a:masterClrMapping/>
   </p:clrMapOvr>
+  <p:timing>
+    <p:tnLst>
+      <p:par>
+        <p:cTn id="1" dur="indefinite" restart="never" nodeType="tmRoot">
+          <p:childTnLst>
+            <p:seq concurrent="1" nextAc="seek">
+              <p:cTn id="2" dur="indefinite" nodeType="mainSeq">
+                <p:childTnLst>
+                  <p:par>
+                    <p:cTn id="3" fill="hold">
+                      <p:stCondLst>
+                        <p:cond delay="indefinite"/>
+                      </p:stCondLst>
+                      <p:childTnLst>
+                        <p:par>
+                          <p:cTn id="4" fill="hold">
+                            <p:stCondLst>
+                              <p:cond delay="0"/>
+                            </p:stCondLst>
+                            <p:childTnLst>
+                              <p:par>
+                                <p:cTn id="5" presetID="1" presetClass="entr" presetSubtype="0" fill="hold" grpId="0" nodeType="clickEffect">
+                                  <p:stCondLst>
+                                    <p:cond delay="0"/>
+                                  </p:stCondLst>
+                                  <p:childTnLst>
+                                    <p:set>
+                                      <p:cBhvr>
+                                        <p:cTn id="6" dur="1" fill="hold">
+                                          <p:stCondLst>
+                                            <p:cond delay="0"/>
+                                          </p:stCondLst>
+                                        </p:cTn>
+                                        <p:tgtEl>
+                                          <p:spTgt spid="3">
+                                            <p:txEl>
+                                              <p:pRg st="0" end="0"/>
+                                            </p:txEl>
+                                          </p:spTgt>
+                                        </p:tgtEl>
+                                        <p:attrNameLst>
+                                          <p:attrName>style.visibility</p:attrName>
+                                        </p:attrNameLst>
+                                      </p:cBhvr>
+                                      <p:to>
+                                        <p:strVal val="visible"/>
+                                      </p:to>
+                                    </p:set>
+                                  </p:childTnLst>
+                                </p:cTn>
+                              </p:par>
+                            </p:childTnLst>
+                          </p:cTn>
+                        </p:par>
+                      </p:childTnLst>
+                    </p:cTn>
+                  </p:par>
+                  <p:par>
+                    <p:cTn id="7" fill="hold">
+                      <p:stCondLst>
+                        <p:cond delay="indefinite"/>
+                      </p:stCondLst>
+                      <p:childTnLst>
+                        <p:par>
+                          <p:cTn id="8" fill="hold">
+                            <p:stCondLst>
+                              <p:cond delay="0"/>
+                            </p:stCondLst>
+                            <p:childTnLst>
+                              <p:par>
+                                <p:cTn id="9" presetID="1" presetClass="entr" presetSubtype="0" fill="hold" grpId="0" nodeType="clickEffect">
+                                  <p:stCondLst>
+                                    <p:cond delay="0"/>
+                                  </p:stCondLst>
+                                  <p:childTnLst>
+                                    <p:set>
+                                      <p:cBhvr>
+                                        <p:cTn id="10" dur="1" fill="hold">
+                                          <p:stCondLst>
+                                            <p:cond delay="0"/>
+                                          </p:stCondLst>
+                                        </p:cTn>
+                                        <p:tgtEl>
+                                          <p:spTgt spid="3">
+                                            <p:txEl>
+                                              <p:pRg st="1" end="1"/>
+                                            </p:txEl>
+                                          </p:spTgt>
+                                        </p:tgtEl>
+                                        <p:attrNameLst>
+                                          <p:attrName>style.visibility</p:attrName>
+                                        </p:attrNameLst>
+                                      </p:cBhvr>
+                                      <p:to>
+                                        <p:strVal val="visible"/>
+                                      </p:to>
+                                    </p:set>
+                                  </p:childTnLst>
+                                </p:cTn>
+                              </p:par>
+                            </p:childTnLst>
+                          </p:cTn>
+                        </p:par>
+                      </p:childTnLst>
+                    </p:cTn>
+                  </p:par>
+                  <p:par>
+                    <p:cTn id="11" fill="hold">
+                      <p:stCondLst>
+                        <p:cond delay="indefinite"/>
+                      </p:stCondLst>
+                      <p:childTnLst>
+                        <p:par>
+                          <p:cTn id="12" fill="hold">
+                            <p:stCondLst>
+                              <p:cond delay="0"/>
+                            </p:stCondLst>
+                            <p:childTnLst>
+                              <p:par>
+                                <p:cTn id="13" presetID="1" presetClass="entr" presetSubtype="0" fill="hold" grpId="0" nodeType="clickEffect">
+                                  <p:stCondLst>
+                                    <p:cond delay="0"/>
+                                  </p:stCondLst>
+                                  <p:childTnLst>
+                                    <p:set>
+                                      <p:cBhvr>
+                                        <p:cTn id="14" dur="1" fill="hold">
+                                          <p:stCondLst>
+                                            <p:cond delay="0"/>
+                                          </p:stCondLst>
+                                        </p:cTn>
+                                        <p:tgtEl>
+                                          <p:spTgt spid="3">
+                                            <p:txEl>
+                                              <p:pRg st="2" end="2"/>
+                                            </p:txEl>
+                                          </p:spTgt>
+                                        </p:tgtEl>
+                                        <p:attrNameLst>
+                                          <p:attrName>style.visibility</p:attrName>
+                                        </p:attrNameLst>
+                                      </p:cBhvr>
+                                      <p:to>
+                                        <p:strVal val="visible"/>
+                                      </p:to>
+                                    </p:set>
+                                  </p:childTnLst>
+                                </p:cTn>
+                              </p:par>
+                            </p:childTnLst>
+                          </p:cTn>
+                        </p:par>
+                      </p:childTnLst>
+                    </p:cTn>
+                  </p:par>
+                  <p:par>
+                    <p:cTn id="15" fill="hold">
+                      <p:stCondLst>
+                        <p:cond delay="indefinite"/>
+                      </p:stCondLst>
+                      <p:childTnLst>
+                        <p:par>
+                          <p:cTn id="16" fill="hold">
+                            <p:stCondLst>
+                              <p:cond delay="0"/>
+                            </p:stCondLst>
+                            <p:childTnLst>
+                              <p:par>
+                                <p:cTn id="17" presetID="1" presetClass="entr" presetSubtype="0" fill="hold" grpId="0" nodeType="clickEffect">
+                                  <p:stCondLst>
+                                    <p:cond delay="0"/>
+                                  </p:stCondLst>
+                                  <p:childTnLst>
+                                    <p:set>
+                                      <p:cBhvr>
+                                        <p:cTn id="18" dur="1" fill="hold">
+                                          <p:stCondLst>
+                                            <p:cond delay="0"/>
+                                          </p:stCondLst>
+                                        </p:cTn>
+                                        <p:tgtEl>
+                                          <p:spTgt spid="3">
+                                            <p:txEl>
+                                              <p:pRg st="3" end="3"/>
+                                            </p:txEl>
+                                          </p:spTgt>
+                                        </p:tgtEl>
+                                        <p:attrNameLst>
+                                          <p:attrName>style.visibility</p:attrName>
+                                        </p:attrNameLst>
+                                      </p:cBhvr>
+                                      <p:to>
+                                        <p:strVal val="visible"/>
+                                      </p:to>
+                                    </p:set>
+                                  </p:childTnLst>
+                                </p:cTn>
+                              </p:par>
+                              <p:par>
+                                <p:cTn id="19" presetID="1" presetClass="entr" presetSubtype="0" fill="hold" grpId="0" nodeType="withEffect">
+                                  <p:stCondLst>
+                                    <p:cond delay="0"/>
+                                  </p:stCondLst>
+                                  <p:childTnLst>
+                                    <p:set>
+                                      <p:cBhvr>
+                                        <p:cTn id="20" dur="1" fill="hold">
+                                          <p:stCondLst>
+                                            <p:cond delay="0"/>
+                                          </p:stCondLst>
+                                        </p:cTn>
+                                        <p:tgtEl>
+                                          <p:spTgt spid="3">
+                                            <p:txEl>
+                                              <p:pRg st="4" end="4"/>
+                                            </p:txEl>
+                                          </p:spTgt>
+                                        </p:tgtEl>
+                                        <p:attrNameLst>
+                                          <p:attrName>style.visibility</p:attrName>
+                                        </p:attrNameLst>
+                                      </p:cBhvr>
+                                      <p:to>
+                                        <p:strVal val="visible"/>
+                                      </p:to>
+                                    </p:set>
+                                  </p:childTnLst>
+                                </p:cTn>
+                              </p:par>
+                              <p:par>
+                                <p:cTn id="21" presetID="1" presetClass="entr" presetSubtype="0" fill="hold" grpId="0" nodeType="withEffect">
+                                  <p:stCondLst>
+                                    <p:cond delay="0"/>
+                                  </p:stCondLst>
+                                  <p:childTnLst>
+                                    <p:set>
+                                      <p:cBhvr>
+                                        <p:cTn id="22" dur="1" fill="hold">
+                                          <p:stCondLst>
+                                            <p:cond delay="0"/>
+                                          </p:stCondLst>
+                                        </p:cTn>
+                                        <p:tgtEl>
+                                          <p:spTgt spid="3">
+                                            <p:txEl>
+                                              <p:pRg st="5" end="5"/>
+                                            </p:txEl>
+                                          </p:spTgt>
+                                        </p:tgtEl>
+                                        <p:attrNameLst>
+                                          <p:attrName>style.visibility</p:attrName>
+                                        </p:attrNameLst>
+                                      </p:cBhvr>
+                                      <p:to>
+                                        <p:strVal val="visible"/>
+                                      </p:to>
+                                    </p:set>
+                                  </p:childTnLst>
+                                </p:cTn>
+                              </p:par>
+                            </p:childTnLst>
+                          </p:cTn>
+                        </p:par>
+                      </p:childTnLst>
+                    </p:cTn>
+                  </p:par>
+                  <p:par>
+                    <p:cTn id="23" fill="hold">
+                      <p:stCondLst>
+                        <p:cond delay="indefinite"/>
+                      </p:stCondLst>
+                      <p:childTnLst>
+                        <p:par>
+                          <p:cTn id="24" fill="hold">
+                            <p:stCondLst>
+                              <p:cond delay="0"/>
+                            </p:stCondLst>
+                            <p:childTnLst>
+                              <p:par>
+                                <p:cTn id="25" presetID="1" presetClass="entr" presetSubtype="0" fill="hold" grpId="0" nodeType="clickEffect">
+                                  <p:stCondLst>
+                                    <p:cond delay="0"/>
+                                  </p:stCondLst>
+                                  <p:childTnLst>
+                                    <p:set>
+                                      <p:cBhvr>
+                                        <p:cTn id="26" dur="1" fill="hold">
+                                          <p:stCondLst>
+                                            <p:cond delay="0"/>
+                                          </p:stCondLst>
+                                        </p:cTn>
+                                        <p:tgtEl>
+                                          <p:spTgt spid="9"/>
+                                        </p:tgtEl>
+                                        <p:attrNameLst>
+                                          <p:attrName>style.visibility</p:attrName>
+                                        </p:attrNameLst>
+                                      </p:cBhvr>
+                                      <p:to>
+                                        <p:strVal val="visible"/>
+                                      </p:to>
+                                    </p:set>
+                                  </p:childTnLst>
+                                </p:cTn>
+                              </p:par>
+                            </p:childTnLst>
+                          </p:cTn>
+                        </p:par>
+                      </p:childTnLst>
+                    </p:cTn>
+                  </p:par>
+                  <p:par>
+                    <p:cTn id="27" fill="hold">
+                      <p:stCondLst>
+                        <p:cond delay="indefinite"/>
+                      </p:stCondLst>
+                      <p:childTnLst>
+                        <p:par>
+                          <p:cTn id="28" fill="hold">
+                            <p:stCondLst>
+                              <p:cond delay="0"/>
+                            </p:stCondLst>
+                            <p:childTnLst>
+                              <p:par>
+                                <p:cTn id="29" presetID="1" presetClass="entr" presetSubtype="0" fill="hold" grpId="0" nodeType="clickEffect">
+                                  <p:stCondLst>
+                                    <p:cond delay="0"/>
+                                  </p:stCondLst>
+                                  <p:childTnLst>
+                                    <p:set>
+                                      <p:cBhvr>
+                                        <p:cTn id="30" dur="1" fill="hold">
+                                          <p:stCondLst>
+                                            <p:cond delay="0"/>
+                                          </p:stCondLst>
+                                        </p:cTn>
+                                        <p:tgtEl>
+                                          <p:spTgt spid="10"/>
+                                        </p:tgtEl>
+                                        <p:attrNameLst>
+                                          <p:attrName>style.visibility</p:attrName>
+                                        </p:attrNameLst>
+                                      </p:cBhvr>
+                                      <p:to>
+                                        <p:strVal val="visible"/>
+                                      </p:to>
+                                    </p:set>
+                                  </p:childTnLst>
+                                </p:cTn>
+                              </p:par>
+                            </p:childTnLst>
+                          </p:cTn>
+                        </p:par>
+                      </p:childTnLst>
+                    </p:cTn>
+                  </p:par>
+                  <p:par>
+                    <p:cTn id="31" fill="hold">
+                      <p:stCondLst>
+                        <p:cond delay="indefinite"/>
+                      </p:stCondLst>
+                      <p:childTnLst>
+                        <p:par>
+                          <p:cTn id="32" fill="hold">
+                            <p:stCondLst>
+                              <p:cond delay="0"/>
+                            </p:stCondLst>
+                            <p:childTnLst>
+                              <p:par>
+                                <p:cTn id="33" presetID="1" presetClass="entr" presetSubtype="0" fill="hold" grpId="0" nodeType="clickEffect">
+                                  <p:stCondLst>
+                                    <p:cond delay="0"/>
+                                  </p:stCondLst>
+                                  <p:childTnLst>
+                                    <p:set>
+                                      <p:cBhvr>
+                                        <p:cTn id="34" dur="1" fill="hold">
+                                          <p:stCondLst>
+                                            <p:cond delay="0"/>
+                                          </p:stCondLst>
+                                        </p:cTn>
+                                        <p:tgtEl>
+                                          <p:spTgt spid="8"/>
+                                        </p:tgtEl>
+                                        <p:attrNameLst>
+                                          <p:attrName>style.visibility</p:attrName>
+                                        </p:attrNameLst>
+                                      </p:cBhvr>
+                                      <p:to>
+                                        <p:strVal val="visible"/>
+                                      </p:to>
+                                    </p:set>
+                                  </p:childTnLst>
+                                </p:cTn>
+                              </p:par>
+                            </p:childTnLst>
+                          </p:cTn>
+                        </p:par>
+                      </p:childTnLst>
+                    </p:cTn>
+                  </p:par>
+                </p:childTnLst>
+              </p:cTn>
+              <p:prevCondLst>
+                <p:cond evt="onPrev" delay="0">
+                  <p:tgtEl>
+                    <p:sldTgt/>
+                  </p:tgtEl>
+                </p:cond>
+              </p:prevCondLst>
+              <p:nextCondLst>
+                <p:cond evt="onNext" delay="0">
+                  <p:tgtEl>
+                    <p:sldTgt/>
+                  </p:tgtEl>
+                </p:cond>
+              </p:nextCondLst>
+            </p:seq>
+          </p:childTnLst>
+        </p:cTn>
+      </p:par>
+    </p:tnLst>
+    <p:bldLst>
+      <p:bldP spid="3" grpId="0" build="p"/>
+      <p:bldP spid="8" grpId="0"/>
+      <p:bldP spid="9" grpId="0"/>
+      <p:bldP spid="10" grpId="0"/>
+    </p:bldLst>
+  </p:timing>
 </p:sld>
 </file>
 
@@ -5475,6 +6066,178 @@
   <p:clrMapOvr>
     <a:masterClrMapping/>
   </p:clrMapOvr>
+  <p:timing>
+    <p:tnLst>
+      <p:par>
+        <p:cTn id="1" dur="indefinite" restart="never" nodeType="tmRoot">
+          <p:childTnLst>
+            <p:seq concurrent="1" nextAc="seek">
+              <p:cTn id="2" dur="indefinite" nodeType="mainSeq">
+                <p:childTnLst>
+                  <p:par>
+                    <p:cTn id="3" fill="hold">
+                      <p:stCondLst>
+                        <p:cond delay="indefinite"/>
+                      </p:stCondLst>
+                      <p:childTnLst>
+                        <p:par>
+                          <p:cTn id="4" fill="hold">
+                            <p:stCondLst>
+                              <p:cond delay="0"/>
+                            </p:stCondLst>
+                            <p:childTnLst>
+                              <p:par>
+                                <p:cTn id="5" presetID="1" presetClass="entr" presetSubtype="0" fill="hold" nodeType="clickEffect">
+                                  <p:stCondLst>
+                                    <p:cond delay="0"/>
+                                  </p:stCondLst>
+                                  <p:childTnLst>
+                                    <p:set>
+                                      <p:cBhvr>
+                                        <p:cTn id="6" dur="1" fill="hold">
+                                          <p:stCondLst>
+                                            <p:cond delay="0"/>
+                                          </p:stCondLst>
+                                        </p:cTn>
+                                        <p:tgtEl>
+                                          <p:spTgt spid="5"/>
+                                        </p:tgtEl>
+                                        <p:attrNameLst>
+                                          <p:attrName>style.visibility</p:attrName>
+                                        </p:attrNameLst>
+                                      </p:cBhvr>
+                                      <p:to>
+                                        <p:strVal val="visible"/>
+                                      </p:to>
+                                    </p:set>
+                                  </p:childTnLst>
+                                </p:cTn>
+                              </p:par>
+                            </p:childTnLst>
+                          </p:cTn>
+                        </p:par>
+                      </p:childTnLst>
+                    </p:cTn>
+                  </p:par>
+                  <p:par>
+                    <p:cTn id="7" fill="hold">
+                      <p:stCondLst>
+                        <p:cond delay="indefinite"/>
+                      </p:stCondLst>
+                      <p:childTnLst>
+                        <p:par>
+                          <p:cTn id="8" fill="hold">
+                            <p:stCondLst>
+                              <p:cond delay="0"/>
+                            </p:stCondLst>
+                            <p:childTnLst>
+                              <p:par>
+                                <p:cTn id="9" presetID="1" presetClass="entr" presetSubtype="0" fill="hold" nodeType="clickEffect">
+                                  <p:stCondLst>
+                                    <p:cond delay="0"/>
+                                  </p:stCondLst>
+                                  <p:childTnLst>
+                                    <p:set>
+                                      <p:cBhvr>
+                                        <p:cTn id="10" dur="1" fill="hold">
+                                          <p:stCondLst>
+                                            <p:cond delay="0"/>
+                                          </p:stCondLst>
+                                        </p:cTn>
+                                        <p:tgtEl>
+                                          <p:spTgt spid="10"/>
+                                        </p:tgtEl>
+                                        <p:attrNameLst>
+                                          <p:attrName>style.visibility</p:attrName>
+                                        </p:attrNameLst>
+                                      </p:cBhvr>
+                                      <p:to>
+                                        <p:strVal val="visible"/>
+                                      </p:to>
+                                    </p:set>
+                                  </p:childTnLst>
+                                </p:cTn>
+                              </p:par>
+                            </p:childTnLst>
+                          </p:cTn>
+                        </p:par>
+                      </p:childTnLst>
+                    </p:cTn>
+                  </p:par>
+                  <p:par>
+                    <p:cTn id="11" fill="hold">
+                      <p:stCondLst>
+                        <p:cond delay="indefinite"/>
+                      </p:stCondLst>
+                      <p:childTnLst>
+                        <p:par>
+                          <p:cTn id="12" fill="hold">
+                            <p:stCondLst>
+                              <p:cond delay="0"/>
+                            </p:stCondLst>
+                            <p:childTnLst>
+                              <p:par>
+                                <p:cTn id="13" presetID="1" presetClass="entr" presetSubtype="0" fill="hold" grpId="0" nodeType="clickEffect">
+                                  <p:stCondLst>
+                                    <p:cond delay="0"/>
+                                  </p:stCondLst>
+                                  <p:childTnLst>
+                                    <p:set>
+                                      <p:cBhvr>
+                                        <p:cTn id="14" dur="1" fill="hold">
+                                          <p:stCondLst>
+                                            <p:cond delay="0"/>
+                                          </p:stCondLst>
+                                        </p:cTn>
+                                        <p:tgtEl>
+                                          <p:spTgt spid="3">
+                                            <p:txEl>
+                                              <p:pRg st="8" end="8"/>
+                                            </p:txEl>
+                                          </p:spTgt>
+                                        </p:tgtEl>
+                                        <p:attrNameLst>
+                                          <p:attrName>style.visibility</p:attrName>
+                                        </p:attrNameLst>
+                                      </p:cBhvr>
+                                      <p:to>
+                                        <p:strVal val="visible"/>
+                                      </p:to>
+                                    </p:set>
+                                  </p:childTnLst>
+                                </p:cTn>
+                              </p:par>
+                            </p:childTnLst>
+                          </p:cTn>
+                        </p:par>
+                      </p:childTnLst>
+                    </p:cTn>
+                  </p:par>
+                </p:childTnLst>
+              </p:cTn>
+              <p:prevCondLst>
+                <p:cond evt="onPrev" delay="0">
+                  <p:tgtEl>
+                    <p:sldTgt/>
+                  </p:tgtEl>
+                </p:cond>
+              </p:prevCondLst>
+              <p:nextCondLst>
+                <p:cond evt="onNext" delay="0">
+                  <p:tgtEl>
+                    <p:sldTgt/>
+                  </p:tgtEl>
+                </p:cond>
+              </p:nextCondLst>
+            </p:seq>
+          </p:childTnLst>
+        </p:cTn>
+      </p:par>
+    </p:tnLst>
+    <p:bldLst>
+      <p:bldP spid="3" grpId="0" uiExpand="1" build="p"/>
+    </p:bldLst>
+  </p:timing>
 </p:sld>
 </file>
 
@@ -5642,6 +6405,85 @@
   <p:clrMapOvr>
     <a:masterClrMapping/>
   </p:clrMapOvr>
+  <p:timing>
+    <p:tnLst>
+      <p:par>
+        <p:cTn id="1" dur="indefinite" restart="never" nodeType="tmRoot">
+          <p:childTnLst>
+            <p:seq concurrent="1" nextAc="seek">
+              <p:cTn id="2" dur="indefinite" nodeType="mainSeq">
+                <p:childTnLst>
+                  <p:par>
+                    <p:cTn id="3" fill="hold">
+                      <p:stCondLst>
+                        <p:cond delay="indefinite"/>
+                      </p:stCondLst>
+                      <p:childTnLst>
+                        <p:par>
+                          <p:cTn id="4" fill="hold">
+                            <p:stCondLst>
+                              <p:cond delay="0"/>
+                            </p:stCondLst>
+                            <p:childTnLst>
+                              <p:par>
+                                <p:cTn id="5" presetID="1" presetClass="entr" presetSubtype="0" fill="hold" nodeType="clickEffect">
+                                  <p:stCondLst>
+                                    <p:cond delay="0"/>
+                                  </p:stCondLst>
+                                  <p:childTnLst>
+                                    <p:set>
+                                      <p:cBhvr>
+                                        <p:cTn id="6" dur="1" fill="hold">
+                                          <p:stCondLst>
+                                            <p:cond delay="0"/>
+                                          </p:stCondLst>
+                                        </p:cTn>
+                                        <p:tgtEl>
+                                          <p:spTgt spid="3">
+                                            <p:txEl>
+                                              <p:pRg st="10" end="10"/>
+                                            </p:txEl>
+                                          </p:spTgt>
+                                        </p:tgtEl>
+                                        <p:attrNameLst>
+                                          <p:attrName>style.visibility</p:attrName>
+                                        </p:attrNameLst>
+                                      </p:cBhvr>
+                                      <p:to>
+                                        <p:strVal val="visible"/>
+                                      </p:to>
+                                    </p:set>
+                                  </p:childTnLst>
+                                </p:cTn>
+                              </p:par>
+                            </p:childTnLst>
+                          </p:cTn>
+                        </p:par>
+                      </p:childTnLst>
+                    </p:cTn>
+                  </p:par>
+                </p:childTnLst>
+              </p:cTn>
+              <p:prevCondLst>
+                <p:cond evt="onPrev" delay="0">
+                  <p:tgtEl>
+                    <p:sldTgt/>
+                  </p:tgtEl>
+                </p:cond>
+              </p:prevCondLst>
+              <p:nextCondLst>
+                <p:cond evt="onNext" delay="0">
+                  <p:tgtEl>
+                    <p:sldTgt/>
+                  </p:tgtEl>
+                </p:cond>
+              </p:nextCondLst>
+            </p:seq>
+          </p:childTnLst>
+        </p:cTn>
+      </p:par>
+    </p:tnLst>
+  </p:timing>
 </p:sld>
 </file>
 
@@ -8959,7 +9801,7 @@
             <a:pPr lvl="2"/>
             <a:r>
               <a:rPr lang="en-US" noProof="1"/>
-              <a:t>exponentiation, using appending integers (e.g. “m2”). “^” is not supported (yet).</a:t>
+              <a:t>exponentiation, using appending integers (e.g. “m2”). “^” is not supported.</a:t>
             </a:r>
           </a:p>
           <a:p>

</xml_diff>

<commit_message>
Several changes, I still don't know how to work with branches, lol
</commit_message>
<xml_diff>
--- a/tuts/antupy.pptx
+++ b/tuts/antupy.pptx
@@ -337,7 +337,7 @@
           <a:p>
             <a:fld id="{BA80F017-51D9-403D-A3B1-D86CBEE1772E}" type="datetimeFigureOut">
               <a:rPr lang="en-AU" smtClean="0"/>
-              <a:t>13/05/2026</a:t>
+              <a:t>20/05/2026</a:t>
             </a:fld>
             <a:endParaRPr lang="en-AU"/>
           </a:p>
@@ -507,7 +507,7 @@
           <a:p>
             <a:fld id="{BA80F017-51D9-403D-A3B1-D86CBEE1772E}" type="datetimeFigureOut">
               <a:rPr lang="en-AU" smtClean="0"/>
-              <a:t>13/05/2026</a:t>
+              <a:t>20/05/2026</a:t>
             </a:fld>
             <a:endParaRPr lang="en-AU"/>
           </a:p>
@@ -687,7 +687,7 @@
           <a:p>
             <a:fld id="{BA80F017-51D9-403D-A3B1-D86CBEE1772E}" type="datetimeFigureOut">
               <a:rPr lang="en-AU" smtClean="0"/>
-              <a:t>13/05/2026</a:t>
+              <a:t>20/05/2026</a:t>
             </a:fld>
             <a:endParaRPr lang="en-AU"/>
           </a:p>
@@ -857,7 +857,7 @@
           <a:p>
             <a:fld id="{BA80F017-51D9-403D-A3B1-D86CBEE1772E}" type="datetimeFigureOut">
               <a:rPr lang="en-AU" smtClean="0"/>
-              <a:t>13/05/2026</a:t>
+              <a:t>20/05/2026</a:t>
             </a:fld>
             <a:endParaRPr lang="en-AU"/>
           </a:p>
@@ -1103,7 +1103,7 @@
           <a:p>
             <a:fld id="{BA80F017-51D9-403D-A3B1-D86CBEE1772E}" type="datetimeFigureOut">
               <a:rPr lang="en-AU" smtClean="0"/>
-              <a:t>13/05/2026</a:t>
+              <a:t>20/05/2026</a:t>
             </a:fld>
             <a:endParaRPr lang="en-AU"/>
           </a:p>
@@ -1335,7 +1335,7 @@
           <a:p>
             <a:fld id="{BA80F017-51D9-403D-A3B1-D86CBEE1772E}" type="datetimeFigureOut">
               <a:rPr lang="en-AU" smtClean="0"/>
-              <a:t>13/05/2026</a:t>
+              <a:t>20/05/2026</a:t>
             </a:fld>
             <a:endParaRPr lang="en-AU"/>
           </a:p>
@@ -1702,7 +1702,7 @@
           <a:p>
             <a:fld id="{BA80F017-51D9-403D-A3B1-D86CBEE1772E}" type="datetimeFigureOut">
               <a:rPr lang="en-AU" smtClean="0"/>
-              <a:t>13/05/2026</a:t>
+              <a:t>20/05/2026</a:t>
             </a:fld>
             <a:endParaRPr lang="en-AU"/>
           </a:p>
@@ -1820,7 +1820,7 @@
           <a:p>
             <a:fld id="{BA80F017-51D9-403D-A3B1-D86CBEE1772E}" type="datetimeFigureOut">
               <a:rPr lang="en-AU" smtClean="0"/>
-              <a:t>13/05/2026</a:t>
+              <a:t>20/05/2026</a:t>
             </a:fld>
             <a:endParaRPr lang="en-AU"/>
           </a:p>
@@ -1915,7 +1915,7 @@
           <a:p>
             <a:fld id="{BA80F017-51D9-403D-A3B1-D86CBEE1772E}" type="datetimeFigureOut">
               <a:rPr lang="en-AU" smtClean="0"/>
-              <a:t>13/05/2026</a:t>
+              <a:t>20/05/2026</a:t>
             </a:fld>
             <a:endParaRPr lang="en-AU"/>
           </a:p>
@@ -2192,7 +2192,7 @@
           <a:p>
             <a:fld id="{BA80F017-51D9-403D-A3B1-D86CBEE1772E}" type="datetimeFigureOut">
               <a:rPr lang="en-AU" smtClean="0"/>
-              <a:t>13/05/2026</a:t>
+              <a:t>20/05/2026</a:t>
             </a:fld>
             <a:endParaRPr lang="en-AU"/>
           </a:p>
@@ -2449,7 +2449,7 @@
           <a:p>
             <a:fld id="{BA80F017-51D9-403D-A3B1-D86CBEE1772E}" type="datetimeFigureOut">
               <a:rPr lang="en-AU" smtClean="0"/>
-              <a:t>13/05/2026</a:t>
+              <a:t>20/05/2026</a:t>
             </a:fld>
             <a:endParaRPr lang="en-AU"/>
           </a:p>
@@ -2662,7 +2662,7 @@
           <a:p>
             <a:fld id="{BA80F017-51D9-403D-A3B1-D86CBEE1772E}" type="datetimeFigureOut">
               <a:rPr lang="en-AU" smtClean="0"/>
-              <a:t>13/05/2026</a:t>
+              <a:t>20/05/2026</a:t>
             </a:fld>
             <a:endParaRPr lang="en-AU"/>
           </a:p>
@@ -9313,7 +9313,7 @@
             <a:pPr lvl="1"/>
             <a:r>
               <a:rPr lang="en-US" noProof="1"/>
-              <a:t>set_value(str) -&gt; Var|Array	(alias su())</a:t>
+              <a:t>set_unit(str) -&gt; Var|Array	(alias su())</a:t>
             </a:r>
           </a:p>
           <a:p>

</xml_diff>